<commit_message>
docs: update PPTX generator script and rebuild presentation.pptx with detailed pipeline details
</commit_message>
<xml_diff>
--- a/docs/presentation.pptx
+++ b/docs/presentation.pptx
@@ -3127,7 +3127,7 @@
               <a:spcAft>
                 <a:spcPts val="800"/>
               </a:spcAft>
-              <a:defRPr sz="5400" b="1">
+              <a:defRPr sz="4800" b="1">
                 <a:solidFill>
                   <a:srgbClr val="F3F4F6"/>
                 </a:solidFill>
@@ -3135,7 +3135,7 @@
               </a:defRPr>
             </a:pPr>
             <a:r>
-              <a:t>AltioStar MRO Training Pipeline</a:t>
+              <a:t>5G MRO RL Pipeline Deep-Dive</a:t>
             </a:r>
           </a:p>
           <a:p>
@@ -3143,7 +3143,7 @@
               <a:spcAft>
                 <a:spcPts val="4800"/>
               </a:spcAft>
-              <a:defRPr sz="2200">
+              <a:defRPr sz="2000">
                 <a:solidFill>
                   <a:srgbClr val="38BDF8"/>
                 </a:solidFill>
@@ -3151,7 +3151,7 @@
               </a:defRPr>
             </a:pPr>
             <a:r>
-              <a:t>Reinforcement Learning loops for 5G Handover Optimization</a:t>
+              <a:t>Under-the-Hood Data Pipeline, Gymnasium Simulation, and Multi-Agent Architecture</a:t>
             </a:r>
           </a:p>
           <a:p>
@@ -3159,7 +3159,7 @@
               <a:spcAft>
                 <a:spcPts val="400"/>
               </a:spcAft>
-              <a:defRPr sz="1800" b="1">
+              <a:defRPr sz="1600" b="1">
                 <a:solidFill>
                   <a:srgbClr val="818CF8"/>
                 </a:solidFill>
@@ -3167,12 +3167,12 @@
               </a:defRPr>
             </a:pPr>
             <a:r>
-              <a:t>Stream 4 | Harshit · Ananyaa · Shourya · Devika</a:t>
-            </a:r>
-          </a:p>
-          <a:p>
-            <a:pPr>
-              <a:defRPr sz="1400">
+              <a:t>AltioStar Tokyo MRO Stream | Devika · Harshit · Ananyaa · Shourya</a:t>
+            </a:r>
+          </a:p>
+          <a:p>
+            <a:pPr>
+              <a:defRPr sz="1300">
                 <a:solidFill>
                   <a:srgbClr val="9CA3AF"/>
                 </a:solidFill>
@@ -3219,7 +3219,7 @@
         </p:nvSpPr>
         <p:spPr>
           <a:xfrm>
-            <a:off x="731520" y="457200"/>
+            <a:off x="731520" y="365760"/>
             <a:ext cx="10698480" cy="1097280"/>
           </a:xfrm>
           <a:prstGeom prst="rect">
@@ -3234,7 +3234,7 @@
           <a:lstStyle/>
           <a:p>
             <a:pPr>
-              <a:defRPr sz="3600" b="1">
+              <a:defRPr sz="3200" b="1">
                 <a:solidFill>
                   <a:srgbClr val="F3F4F6"/>
                 </a:solidFill>
@@ -3242,12 +3242,12 @@
               </a:defRPr>
             </a:pPr>
             <a:r>
-              <a:t>Phase 0: Foundational Setup</a:t>
-            </a:r>
-          </a:p>
-          <a:p>
-            <a:pPr>
-              <a:defRPr sz="1400" b="1">
+              <a:t>The Ingestion Data Pipeline</a:t>
+            </a:r>
+          </a:p>
+          <a:p>
+            <a:pPr>
+              <a:defRPr sz="1300" b="1">
                 <a:solidFill>
                   <a:srgbClr val="38BDF8"/>
                 </a:solidFill>
@@ -3255,7 +3255,7 @@
               </a:defRPr>
             </a:pPr>
             <a:r>
-              <a:t>// Foundation Checkpoint</a:t>
+              <a:t>// Data Engineering</a:t>
             </a:r>
           </a:p>
         </p:txBody>
@@ -3268,8 +3268,8 @@
         </p:nvSpPr>
         <p:spPr>
           <a:xfrm>
-            <a:off x="731520" y="1828800"/>
-            <a:ext cx="5943600" cy="4114800"/>
+            <a:off x="731520" y="1645920"/>
+            <a:ext cx="5943600" cy="4572000"/>
           </a:xfrm>
           <a:prstGeom prst="rect">
             <a:avLst/>
@@ -3284,9 +3284,9 @@
           <a:p>
             <a:pPr>
               <a:spcAft>
-                <a:spcPts val="400"/>
-              </a:spcAft>
-              <a:defRPr sz="1800" b="1">
+                <a:spcPts val="200"/>
+              </a:spcAft>
+              <a:defRPr sz="1600" b="1">
                 <a:solidFill>
                   <a:srgbClr val="F3F4F6"/>
                 </a:solidFill>
@@ -3294,15 +3294,15 @@
               </a:defRPr>
             </a:pPr>
             <a:r>
-              <a:t>• Dev Environment Bootstrap</a:t>
-            </a:r>
-          </a:p>
-          <a:p>
-            <a:pPr>
-              <a:spcAft>
-                <a:spcPts val="1600"/>
-              </a:spcAft>
-              <a:defRPr sz="1400">
+              <a:t>• Raw Operator CSV Files</a:t>
+            </a:r>
+          </a:p>
+          <a:p>
+            <a:pPr>
+              <a:spcAft>
+                <a:spcPts val="1200"/>
+              </a:spcAft>
+              <a:defRPr sz="1300">
                 <a:solidFill>
                   <a:srgbClr val="9CA3AF"/>
                 </a:solidFill>
@@ -3310,15 +3310,15 @@
               </a:defRPr>
             </a:pPr>
             <a:r>
-              <a:t>  Configured standard local runtimes (Gymnasium, PyTorch, Stable Baselines3, MLflow) on developers' platforms.</a:t>
-            </a:r>
-          </a:p>
-          <a:p>
-            <a:pPr>
-              <a:spcAft>
-                <a:spcPts val="400"/>
-              </a:spcAft>
-              <a:defRPr sz="1800" b="1">
+              <a:t>  Ingests 4 base files: site database (75 cells), neighbor relations (763 pairs), PM data (216K rows), and monthly KPI summary (75 rows).</a:t>
+            </a:r>
+          </a:p>
+          <a:p>
+            <a:pPr>
+              <a:spcAft>
+                <a:spcPts val="200"/>
+              </a:spcAft>
+              <a:defRPr sz="1600" b="1">
                 <a:solidFill>
                   <a:srgbClr val="F3F4F6"/>
                 </a:solidFill>
@@ -3326,15 +3326,15 @@
               </a:defRPr>
             </a:pPr>
             <a:r>
-              <a:t>• Cell-Level Gymnasium Environment</a:t>
-            </a:r>
-          </a:p>
-          <a:p>
-            <a:pPr>
-              <a:spcAft>
-                <a:spcPts val="1600"/>
-              </a:spcAft>
-              <a:defRPr sz="1400">
+              <a:t>• Relation-Level Compilation</a:t>
+            </a:r>
+          </a:p>
+          <a:p>
+            <a:pPr>
+              <a:spcAft>
+                <a:spcPts val="1200"/>
+              </a:spcAft>
+              <a:defRPr sz="1300">
                 <a:solidFill>
                   <a:srgbClr val="9CA3AF"/>
                 </a:solidFill>
@@ -3342,15 +3342,15 @@
               </a:defRPr>
             </a:pPr>
             <a:r>
-              <a:t>  Built MROEnv mapping cell parameters (Power, Tilt, CIO) to simulated ROP action modifications and KPI returns.</a:t>
-            </a:r>
-          </a:p>
-          <a:p>
-            <a:pPr>
-              <a:spcAft>
-                <a:spcPts val="400"/>
-              </a:spcAft>
-              <a:defRPr sz="1800" b="1">
+              <a:t>  Merges and compiles cell-level PM and relation parameters into a high-granularity 2.2M-row relation-level PM dataset (pm_data_relation_level.csv).</a:t>
+            </a:r>
+          </a:p>
+          <a:p>
+            <a:pPr>
+              <a:spcAft>
+                <a:spcPts val="200"/>
+              </a:spcAft>
+              <a:defRPr sz="1600" b="1">
                 <a:solidFill>
                   <a:srgbClr val="F3F4F6"/>
                 </a:solidFill>
@@ -3358,15 +3358,15 @@
               </a:defRPr>
             </a:pPr>
             <a:r>
-              <a:t>• Synthetic Data Ingestion</a:t>
-            </a:r>
-          </a:p>
-          <a:p>
-            <a:pPr>
-              <a:spcAft>
-                <a:spcPts val="1600"/>
-              </a:spcAft>
-              <a:defRPr sz="1400">
+              <a:t>• Set-Based Schema Mapper</a:t>
+            </a:r>
+          </a:p>
+          <a:p>
+            <a:pPr>
+              <a:spcAft>
+                <a:spcPts val="1200"/>
+              </a:spcAft>
+              <a:defRPr sz="1300">
                 <a:solidFill>
                   <a:srgbClr val="9CA3AF"/>
                 </a:solidFill>
@@ -3374,15 +3374,15 @@
               </a:defRPr>
             </a:pPr>
             <a:r>
-              <a:t>  Integrated parser systems loading mock cluster metrics to feed env steps dynamically.</a:t>
-            </a:r>
-          </a:p>
-          <a:p>
-            <a:pPr>
-              <a:spcAft>
-                <a:spcPts val="400"/>
-              </a:spcAft>
-              <a:defRPr sz="1800" b="1">
+              <a:t>  Auto-detects CSV types and maps columns. Uses set signature matching (cols.issubset) in schema_mapper.py to remain 100% order-independent (shuffled column proof).</a:t>
+            </a:r>
+          </a:p>
+          <a:p>
+            <a:pPr>
+              <a:spcAft>
+                <a:spcPts val="200"/>
+              </a:spcAft>
+              <a:defRPr sz="1600" b="1">
                 <a:solidFill>
                   <a:srgbClr val="F3F4F6"/>
                 </a:solidFill>
@@ -3390,15 +3390,15 @@
               </a:defRPr>
             </a:pPr>
             <a:r>
-              <a:t>• Verification testing</a:t>
-            </a:r>
-          </a:p>
-          <a:p>
-            <a:pPr>
-              <a:spcAft>
-                <a:spcPts val="1600"/>
-              </a:spcAft>
-              <a:defRPr sz="1400">
+              <a:t>• Double Caching Performance</a:t>
+            </a:r>
+          </a:p>
+          <a:p>
+            <a:pPr>
+              <a:spcAft>
+                <a:spcPts val="1200"/>
+              </a:spcAft>
+              <a:defRPr sz="1300">
                 <a:solidFill>
                   <a:srgbClr val="9CA3AF"/>
                 </a:solidFill>
@@ -3406,7 +3406,7 @@
               </a:defRPr>
             </a:pPr>
             <a:r>
-              <a:t>  Created regression checking utilities for step values, rewards, and telemetry integrity.</a:t>
+              <a:t>  Caches dataframes and pre-grouped relation slices in memory to reduce env boot time from minutes to under 50 milliseconds.</a:t>
             </a:r>
           </a:p>
         </p:txBody>
@@ -3419,8 +3419,8 @@
         </p:nvSpPr>
         <p:spPr>
           <a:xfrm>
-            <a:off x="7315200" y="1828800"/>
-            <a:ext cx="4114800" cy="4114800"/>
+            <a:off x="7132320" y="1645920"/>
+            <a:ext cx="4297680" cy="4572000"/>
           </a:xfrm>
           <a:prstGeom prst="rect">
             <a:avLst/>
@@ -3435,9 +3435,9 @@
           <a:p>
             <a:pPr>
               <a:spcAft>
-                <a:spcPts val="2000"/>
-              </a:spcAft>
-              <a:defRPr sz="2800" b="1">
+                <a:spcPts val="1600"/>
+              </a:spcAft>
+              <a:defRPr sz="2200" b="1">
                 <a:solidFill>
                   <a:srgbClr val="38BDF8"/>
                 </a:solidFill>
@@ -3445,12 +3445,12 @@
               </a:defRPr>
             </a:pPr>
             <a:r>
-              <a:t>🚀 tag: v0.1.0</a:t>
-            </a:r>
-          </a:p>
-          <a:p>
-            <a:pPr>
-              <a:defRPr sz="1800">
+              <a:t>📊 CSV to State Lifecycle</a:t>
+            </a:r>
+          </a:p>
+          <a:p>
+            <a:pPr>
+              <a:defRPr sz="1600">
                 <a:solidFill>
                   <a:srgbClr val="F3F4F6"/>
                 </a:solidFill>
@@ -3458,11 +3458,31 @@
               </a:defRPr>
             </a:pPr>
             <a:r>
-              <a:t>Outcome:</a:t>
+              <a:t>1. Raw CSV Ingestion</a:t>
             </a:r>
             <a:br/>
             <a:r>
-              <a:t>Verified a stable local runtime pipeline ready to ingest reinforcement learning training runs.</a:t>
+              <a:t>   ↓</a:t>
+            </a:r>
+            <a:br/>
+            <a:r>
+              <a:t>2. Set-based Signature Mapping (schema_mapper.py)</a:t>
+            </a:r>
+            <a:br/>
+            <a:r>
+              <a:t>   ↓</a:t>
+            </a:r>
+            <a:br/>
+            <a:r>
+              <a:t>3. Pre-Grouped Relation Indices Caching</a:t>
+            </a:r>
+            <a:br/>
+            <a:r>
+              <a:t>   ↓</a:t>
+            </a:r>
+            <a:br/>
+            <a:r>
+              <a:t>4. Fast O(1) Gymnasium Env Access</a:t>
             </a:r>
           </a:p>
         </p:txBody>
@@ -3501,7 +3521,7 @@
         </p:nvSpPr>
         <p:spPr>
           <a:xfrm>
-            <a:off x="731520" y="457200"/>
+            <a:off x="731520" y="365760"/>
             <a:ext cx="10698480" cy="1097280"/>
           </a:xfrm>
           <a:prstGeom prst="rect">
@@ -3516,7 +3536,7 @@
           <a:lstStyle/>
           <a:p>
             <a:pPr>
-              <a:defRPr sz="3600" b="1">
+              <a:defRPr sz="3200" b="1">
                 <a:solidFill>
                   <a:srgbClr val="F3F4F6"/>
                 </a:solidFill>
@@ -3524,12 +3544,12 @@
               </a:defRPr>
             </a:pPr>
             <a:r>
-              <a:t>Phase 1: Core Pipeline &amp; Training</a:t>
-            </a:r>
-          </a:p>
-          <a:p>
-            <a:pPr>
-              <a:defRPr sz="1400" b="1">
+              <a:t>Gymnasium Environment Simulation</a:t>
+            </a:r>
+          </a:p>
+          <a:p>
+            <a:pPr>
+              <a:defRPr sz="1300" b="1">
                 <a:solidFill>
                   <a:srgbClr val="38BDF8"/>
                 </a:solidFill>
@@ -3537,7 +3557,7 @@
               </a:defRPr>
             </a:pPr>
             <a:r>
-              <a:t>// Core Development</a:t>
+              <a:t>// Under the Hood</a:t>
             </a:r>
           </a:p>
         </p:txBody>
@@ -3550,8 +3570,8 @@
         </p:nvSpPr>
         <p:spPr>
           <a:xfrm>
-            <a:off x="731520" y="1828800"/>
-            <a:ext cx="5943600" cy="4114800"/>
+            <a:off x="731520" y="1645920"/>
+            <a:ext cx="5943600" cy="4572000"/>
           </a:xfrm>
           <a:prstGeom prst="rect">
             <a:avLst/>
@@ -3566,9 +3586,9 @@
           <a:p>
             <a:pPr>
               <a:spcAft>
-                <a:spcPts val="400"/>
-              </a:spcAft>
-              <a:defRPr sz="1800" b="1">
+                <a:spcPts val="200"/>
+              </a:spcAft>
+              <a:defRPr sz="1600" b="1">
                 <a:solidFill>
                   <a:srgbClr val="F3F4F6"/>
                 </a:solidFill>
@@ -3576,15 +3596,15 @@
               </a:defRPr>
             </a:pPr>
             <a:r>
-              <a:t>• Relation-Level Environment (v2)</a:t>
-            </a:r>
-          </a:p>
-          <a:p>
-            <a:pPr>
-              <a:spcAft>
-                <a:spcPts val="1600"/>
-              </a:spcAft>
-              <a:defRPr sz="1400">
+              <a:t>• Observation Space</a:t>
+            </a:r>
+          </a:p>
+          <a:p>
+            <a:pPr>
+              <a:spcAft>
+                <a:spcPts val="1200"/>
+              </a:spcAft>
+              <a:defRPr sz="1300">
                 <a:solidFill>
                   <a:srgbClr val="9CA3AF"/>
                 </a:solidFill>
@@ -3592,15 +3612,15 @@
               </a:defRPr>
             </a:pPr>
             <a:r>
-              <a:t>  Extended MROEnv to support granular relation pairs (source cell → target cell), handling 763 relations dynamically.</a:t>
-            </a:r>
-          </a:p>
-          <a:p>
-            <a:pPr>
-              <a:spcAft>
-                <a:spcPts val="400"/>
-              </a:spcAft>
-              <a:defRPr sz="1800" b="1">
+              <a:t>  9-dimensional vector per relation (handover attempts, successes, failures: too early, too late, wrong cell, correct cell, ping-pongs, average RSRP/SINR).</a:t>
+            </a:r>
+          </a:p>
+          <a:p>
+            <a:pPr>
+              <a:spcAft>
+                <a:spcPts val="200"/>
+              </a:spcAft>
+              <a:defRPr sz="1600" b="1">
                 <a:solidFill>
                   <a:srgbClr val="F3F4F6"/>
                 </a:solidFill>
@@ -3608,15 +3628,15 @@
               </a:defRPr>
             </a:pPr>
             <a:r>
-              <a:t>• SB3 PPO Agent Convergence Loop</a:t>
-            </a:r>
-          </a:p>
-          <a:p>
-            <a:pPr>
-              <a:spcAft>
-                <a:spcPts val="1600"/>
-              </a:spcAft>
-              <a:defRPr sz="1400">
+              <a:t>• Action Space</a:t>
+            </a:r>
+          </a:p>
+          <a:p>
+            <a:pPr>
+              <a:spcAft>
+                <a:spcPts val="1200"/>
+              </a:spcAft>
+              <a:defRPr sz="1300">
                 <a:solidFill>
                   <a:srgbClr val="9CA3AF"/>
                 </a:solidFill>
@@ -3624,15 +3644,15 @@
               </a:defRPr>
             </a:pPr>
             <a:r>
-              <a:t>  Configured RL policy loops evaluated over consecutive epoch episodes.</a:t>
-            </a:r>
-          </a:p>
-          <a:p>
-            <a:pPr>
-              <a:spcAft>
-                <a:spcPts val="400"/>
-              </a:spcAft>
-              <a:defRPr sz="1800" b="1">
+              <a:t>  Continuous Cell Individual Offset (CIO) delta adjustments per neighbor relation, bounded strictly to [-2.0, 2.0] dB.</a:t>
+            </a:r>
+          </a:p>
+          <a:p>
+            <a:pPr>
+              <a:spcAft>
+                <a:spcPts val="200"/>
+              </a:spcAft>
+              <a:defRPr sz="1600" b="1">
                 <a:solidFill>
                   <a:srgbClr val="F3F4F6"/>
                 </a:solidFill>
@@ -3640,15 +3660,15 @@
               </a:defRPr>
             </a:pPr>
             <a:r>
-              <a:t>• Optuna Hyperparameter Sweeps</a:t>
-            </a:r>
-          </a:p>
-          <a:p>
-            <a:pPr>
-              <a:spcAft>
-                <a:spcPts val="1600"/>
-              </a:spcAft>
-              <a:defRPr sz="1400">
+              <a:t>• Data-Driven State Transitions</a:t>
+            </a:r>
+          </a:p>
+          <a:p>
+            <a:pPr>
+              <a:spcAft>
+                <a:spcPts val="1200"/>
+              </a:spcAft>
+              <a:defRPr sz="1300">
                 <a:solidFill>
                   <a:srgbClr val="9CA3AF"/>
                 </a:solidFill>
@@ -3656,15 +3676,15 @@
               </a:defRPr>
             </a:pPr>
             <a:r>
-              <a:t>  Implemented automated sweeps tuning learning rate, batch size, steps, and discount factor (Gamma) with PPO.</a:t>
-            </a:r>
-          </a:p>
-          <a:p>
-            <a:pPr>
-              <a:spcAft>
-                <a:spcPts val="400"/>
-              </a:spcAft>
-              <a:defRPr sz="1800" b="1">
+              <a:t>  No slow physical propagation math. Environment performs binary search to find the nearest historical CIO database configuration and samples outcomes from the real distribution.</a:t>
+            </a:r>
+          </a:p>
+          <a:p>
+            <a:pPr>
+              <a:spcAft>
+                <a:spcPts val="200"/>
+              </a:spcAft>
+              <a:defRPr sz="1600" b="1">
                 <a:solidFill>
                   <a:srgbClr val="F3F4F6"/>
                 </a:solidFill>
@@ -3672,15 +3692,15 @@
               </a:defRPr>
             </a:pPr>
             <a:r>
-              <a:t>• Clean Tracking &amp; Double Caching</a:t>
-            </a:r>
-          </a:p>
-          <a:p>
-            <a:pPr>
-              <a:spcAft>
-                <a:spcPts val="1600"/>
-              </a:spcAft>
-              <a:defRPr sz="1400">
+              <a:t>• Fast Step Simulation</a:t>
+            </a:r>
+          </a:p>
+          <a:p>
+            <a:pPr>
+              <a:spcAft>
+                <a:spcPts val="1200"/>
+              </a:spcAft>
+              <a:defRPr sz="1300">
                 <a:solidFill>
                   <a:srgbClr val="9CA3AF"/>
                 </a:solidFill>
@@ -3688,7 +3708,7 @@
               </a:defRPr>
             </a:pPr>
             <a:r>
-              <a:t>  Resolved MLflow space encoding path bugs and cached dataframes to cut test runtime from hours to 18 seconds.</a:t>
+              <a:t>  Optimized grouping and caches yield O(1) transitions, allowing 100k rollout steps to run in seconds on CPU.</a:t>
             </a:r>
           </a:p>
         </p:txBody>
@@ -3701,8 +3721,8 @@
         </p:nvSpPr>
         <p:spPr>
           <a:xfrm>
-            <a:off x="7315200" y="1828800"/>
-            <a:ext cx="4114800" cy="4114800"/>
+            <a:off x="7132320" y="1645920"/>
+            <a:ext cx="4297680" cy="4572000"/>
           </a:xfrm>
           <a:prstGeom prst="rect">
             <a:avLst/>
@@ -3717,9 +3737,9 @@
           <a:p>
             <a:pPr>
               <a:spcAft>
-                <a:spcPts val="2000"/>
-              </a:spcAft>
-              <a:defRPr sz="2800" b="1">
+                <a:spcPts val="1600"/>
+              </a:spcAft>
+              <a:defRPr sz="2200" b="1">
                 <a:solidFill>
                   <a:srgbClr val="38BDF8"/>
                 </a:solidFill>
@@ -3727,12 +3747,12 @@
               </a:defRPr>
             </a:pPr>
             <a:r>
-              <a:t>🔥 tag: v0.2.0</a:t>
-            </a:r>
-          </a:p>
-          <a:p>
-            <a:pPr>
-              <a:defRPr sz="1800">
+              <a:t>🧠 Simulation Model</a:t>
+            </a:r>
+          </a:p>
+          <a:p>
+            <a:pPr>
+              <a:defRPr sz="1600">
                 <a:solidFill>
                   <a:srgbClr val="F3F4F6"/>
                 </a:solidFill>
@@ -3740,11 +3760,7 @@
               </a:defRPr>
             </a:pPr>
             <a:r>
-              <a:t>Status: 100% Complete</a:t>
-            </a:r>
-            <a:br/>
-            <a:r>
-              <a:t>Passed 144 unit tests, fully green status on Ruff &amp; Mypy, and merged cleanly to staging.</a:t>
+              <a:t>Physics modeling is slow and error-prone. By slicing the 2.2M-row database and caching outcomes per relation, the env acts as a high-fidelity lookup simulator that behaves exactly like the real radio network.</a:t>
             </a:r>
           </a:p>
         </p:txBody>
@@ -3783,7 +3799,7 @@
         </p:nvSpPr>
         <p:spPr>
           <a:xfrm>
-            <a:off x="731520" y="457200"/>
+            <a:off x="731520" y="365760"/>
             <a:ext cx="10698480" cy="1097280"/>
           </a:xfrm>
           <a:prstGeom prst="rect">
@@ -3798,7 +3814,7 @@
           <a:lstStyle/>
           <a:p>
             <a:pPr>
-              <a:defRPr sz="3600" b="1">
+              <a:defRPr sz="3200" b="1">
                 <a:solidFill>
                   <a:srgbClr val="F3F4F6"/>
                 </a:solidFill>
@@ -3806,12 +3822,12 @@
               </a:defRPr>
             </a:pPr>
             <a:r>
-              <a:t>Entire Training Pipeline Architecture</a:t>
-            </a:r>
-          </a:p>
-          <a:p>
-            <a:pPr>
-              <a:defRPr sz="1400" b="1">
+              <a:t>Reward Engineering &amp; Ship Gate</a:t>
+            </a:r>
+          </a:p>
+          <a:p>
+            <a:pPr>
+              <a:defRPr sz="1300" b="1">
                 <a:solidFill>
                   <a:srgbClr val="38BDF8"/>
                 </a:solidFill>
@@ -3819,7 +3835,7 @@
               </a:defRPr>
             </a:pPr>
             <a:r>
-              <a:t>// System Architecture</a:t>
+              <a:t>// Model Safety</a:t>
             </a:r>
           </a:p>
         </p:txBody>
@@ -3832,8 +3848,8 @@
         </p:nvSpPr>
         <p:spPr>
           <a:xfrm>
-            <a:off x="731520" y="1828800"/>
-            <a:ext cx="5029200" cy="4114800"/>
+            <a:off x="731520" y="1645920"/>
+            <a:ext cx="5943600" cy="4572000"/>
           </a:xfrm>
           <a:prstGeom prst="rect">
             <a:avLst/>
@@ -3848,7 +3864,7 @@
           <a:p>
             <a:pPr>
               <a:spcAft>
-                <a:spcPts val="400"/>
+                <a:spcPts val="200"/>
               </a:spcAft>
               <a:defRPr sz="1600" b="1">
                 <a:solidFill>
@@ -3858,15 +3874,15 @@
               </a:defRPr>
             </a:pPr>
             <a:r>
-              <a:t>• 1. Data Layer Ingestion</a:t>
-            </a:r>
-          </a:p>
-          <a:p>
-            <a:pPr>
-              <a:spcAft>
-                <a:spcPts val="1600"/>
-              </a:spcAft>
-              <a:defRPr sz="1200">
+              <a:t>• v2 Rate-Based Reward</a:t>
+            </a:r>
+          </a:p>
+          <a:p>
+            <a:pPr>
+              <a:spcAft>
+                <a:spcPts val="1200"/>
+              </a:spcAft>
+              <a:defRPr sz="1300">
                 <a:solidFill>
                   <a:srgbClr val="9CA3AF"/>
                 </a:solidFill>
@@ -3874,13 +3890,13 @@
               </a:defRPr>
             </a:pPr>
             <a:r>
-              <a:t>  Reads pm_data_relation_level.csv (142MB containing 2.2M rows).</a:t>
-            </a:r>
-          </a:p>
-          <a:p>
-            <a:pPr>
-              <a:spcAft>
-                <a:spcPts val="400"/>
+              <a:t>  Normalizes by percentage rates directly (bounded and consistent): Reward = HOSR * 1.0 - failure_rate * 5.0 - PP_rate * 2.0.</a:t>
+            </a:r>
+          </a:p>
+          <a:p>
+            <a:pPr>
+              <a:spcAft>
+                <a:spcPts val="200"/>
               </a:spcAft>
               <a:defRPr sz="1600" b="1">
                 <a:solidFill>
@@ -3890,15 +3906,15 @@
               </a:defRPr>
             </a:pPr>
             <a:r>
-              <a:t>• 2. Validation &amp; Caching</a:t>
-            </a:r>
-          </a:p>
-          <a:p>
-            <a:pPr>
-              <a:spcAft>
-                <a:spcPts val="1600"/>
-              </a:spcAft>
-              <a:defRPr sz="1200">
+              <a:t>• Asymmetric Boundary Penalties</a:t>
+            </a:r>
+          </a:p>
+          <a:p>
+            <a:pPr>
+              <a:spcAft>
+                <a:spcPts val="1200"/>
+              </a:spcAft>
+              <a:defRPr sz="1300">
                 <a:solidFill>
                   <a:srgbClr val="9CA3AF"/>
                 </a:solidFill>
@@ -3906,13 +3922,13 @@
               </a:defRPr>
             </a:pPr>
             <a:r>
-              <a:t>  Schema checks in schema_mapper.py / Cache layer optimizes boot times.</a:t>
-            </a:r>
-          </a:p>
-          <a:p>
-            <a:pPr>
-              <a:spcAft>
-                <a:spcPts val="400"/>
+              <a:t>  Introduces asymmetric barrier functions to env (punishes HOSR &lt; 95% and PP &gt; 5% with large negative penalties) to guide PPO policy convergence.</a:t>
+            </a:r>
+          </a:p>
+          <a:p>
+            <a:pPr>
+              <a:spcAft>
+                <a:spcPts val="200"/>
               </a:spcAft>
               <a:defRPr sz="1600" b="1">
                 <a:solidFill>
@@ -3922,15 +3938,15 @@
               </a:defRPr>
             </a:pPr>
             <a:r>
-              <a:t>• 3. Gymnasium Simulation</a:t>
-            </a:r>
-          </a:p>
-          <a:p>
-            <a:pPr>
-              <a:spcAft>
-                <a:spcPts val="1600"/>
-              </a:spcAft>
-              <a:defRPr sz="1200">
+              <a:t>• Automated Ship Gate Validator</a:t>
+            </a:r>
+          </a:p>
+          <a:p>
+            <a:pPr>
+              <a:spcAft>
+                <a:spcPts val="1200"/>
+              </a:spcAft>
+              <a:defRPr sz="1300">
                 <a:solidFill>
                   <a:srgbClr val="9CA3AF"/>
                 </a:solidFill>
@@ -3938,7 +3954,39 @@
               </a:defRPr>
             </a:pPr>
             <a:r>
-              <a:t>  MROEnv runs relation step changes (observes 763 × 9 vectors, adjusts CIO deltas).</a:t>
+              <a:t>  Built ship_gate.py checking results against strictly HOSR &gt; 99% and PP &lt; 5%. Outputs exit code 0/1 for CI/CD gates.</a:t>
+            </a:r>
+          </a:p>
+          <a:p>
+            <a:pPr>
+              <a:spcAft>
+                <a:spcPts val="200"/>
+              </a:spcAft>
+              <a:defRPr sz="1600" b="1">
+                <a:solidFill>
+                  <a:srgbClr val="F3F4F6"/>
+                </a:solidFill>
+                <a:latin typeface="Arial"/>
+              </a:defRPr>
+            </a:pPr>
+            <a:r>
+              <a:t>• Statistical Significance Check</a:t>
+            </a:r>
+          </a:p>
+          <a:p>
+            <a:pPr>
+              <a:spcAft>
+                <a:spcPts val="1200"/>
+              </a:spcAft>
+              <a:defRPr sz="1300">
+                <a:solidFill>
+                  <a:srgbClr val="9CA3AF"/>
+                </a:solidFill>
+                <a:latin typeface="Arial"/>
+              </a:defRPr>
+            </a:pPr>
+            <a:r>
+              <a:t>  Evaluates sweep results across 5 independent seeds to ensure repeatability and prevent random seed selection bias.</a:t>
             </a:r>
           </a:p>
         </p:txBody>
@@ -3951,8 +3999,8 @@
         </p:nvSpPr>
         <p:spPr>
           <a:xfrm>
-            <a:off x="6217920" y="1828800"/>
-            <a:ext cx="5029200" cy="4114800"/>
+            <a:off x="7132320" y="1645920"/>
+            <a:ext cx="4297680" cy="4572000"/>
           </a:xfrm>
           <a:prstGeom prst="rect">
             <a:avLst/>
@@ -3960,16 +4008,29 @@
           <a:noFill/>
         </p:spPr>
         <p:txBody>
-          <a:bodyPr wrap="square" lIns="0" tIns="0" rIns="0" bIns="0">
+          <a:bodyPr wrap="square">
             <a:spAutoFit/>
           </a:bodyPr>
           <a:lstStyle/>
           <a:p>
             <a:pPr>
               <a:spcAft>
-                <a:spcPts val="400"/>
-              </a:spcAft>
-              <a:defRPr sz="1600" b="1">
+                <a:spcPts val="1600"/>
+              </a:spcAft>
+              <a:defRPr sz="2200" b="1">
+                <a:solidFill>
+                  <a:srgbClr val="38BDF8"/>
+                </a:solidFill>
+                <a:latin typeface="Arial"/>
+              </a:defRPr>
+            </a:pPr>
+            <a:r>
+              <a:t>🛡️ Ship Gate Criteria</a:t>
+            </a:r>
+          </a:p>
+          <a:p>
+            <a:pPr>
+              <a:defRPr sz="1600">
                 <a:solidFill>
                   <a:srgbClr val="F3F4F6"/>
                 </a:solidFill>
@@ -3977,87 +4038,16 @@
               </a:defRPr>
             </a:pPr>
             <a:r>
-              <a:t>• 4. SB3 PPO Training Loop</a:t>
-            </a:r>
-          </a:p>
-          <a:p>
-            <a:pPr>
-              <a:spcAft>
-                <a:spcPts val="1600"/>
-              </a:spcAft>
-              <a:defRPr sz="1200">
-                <a:solidFill>
-                  <a:srgbClr val="9CA3AF"/>
-                </a:solidFill>
-                <a:latin typeface="Arial"/>
-              </a:defRPr>
-            </a:pPr>
-            <a:r>
-              <a:t>  PPO policy loops optimize parameters over rollouts (train_relation_ppo.py).</a:t>
-            </a:r>
-          </a:p>
-          <a:p>
-            <a:pPr>
-              <a:spcAft>
-                <a:spcPts val="400"/>
-              </a:spcAft>
-              <a:defRPr sz="1600" b="1">
-                <a:solidFill>
-                  <a:srgbClr val="F3F4F6"/>
-                </a:solidFill>
-                <a:latin typeface="Arial"/>
-              </a:defRPr>
-            </a:pPr>
-            <a:r>
-              <a:t>• 5. Tracking &amp; Model Store</a:t>
-            </a:r>
-          </a:p>
-          <a:p>
-            <a:pPr>
-              <a:spcAft>
-                <a:spcPts val="1600"/>
-              </a:spcAft>
-              <a:defRPr sz="1200">
-                <a:solidFill>
-                  <a:srgbClr val="9CA3AF"/>
-                </a:solidFill>
-                <a:latin typeface="Arial"/>
-              </a:defRPr>
-            </a:pPr>
-            <a:r>
-              <a:t>  Logs trial parameters and convergence metrics to local SQLite database (mlflow.db).</a:t>
-            </a:r>
-          </a:p>
-          <a:p>
-            <a:pPr>
-              <a:spcAft>
-                <a:spcPts val="400"/>
-              </a:spcAft>
-              <a:defRPr sz="1600" b="1">
-                <a:solidFill>
-                  <a:srgbClr val="F3F4F6"/>
-                </a:solidFill>
-                <a:latin typeface="Arial"/>
-              </a:defRPr>
-            </a:pPr>
-            <a:r>
-              <a:t>• 6. Dashboard Visualizer</a:t>
-            </a:r>
-          </a:p>
-          <a:p>
-            <a:pPr>
-              <a:spcAft>
-                <a:spcPts val="1600"/>
-              </a:spcAft>
-              <a:defRPr sz="1200">
-                <a:solidFill>
-                  <a:srgbClr val="9CA3AF"/>
-                </a:solidFill>
-                <a:latin typeface="Arial"/>
-              </a:defRPr>
-            </a:pPr>
-            <a:r>
-              <a:t>  Streamlit app pulls mlflow_run_id results for comparative charts against random baseline.</a:t>
+              <a:t>• HOSR: Strictly &gt; 99.0% (99.0% = FAIL)</a:t>
+            </a:r>
+            <a:br/>
+            <a:r>
+              <a:t>• Ping-Pong: Strictly &lt; 5.0% (5.0% = FAIL)</a:t>
+            </a:r>
+            <a:br/>
+            <a:br/>
+            <a:r>
+              <a:t>Checked automatically on every sweep results JSON file before code merges to staging.</a:t>
             </a:r>
           </a:p>
         </p:txBody>
@@ -4096,7 +4086,7 @@
         </p:nvSpPr>
         <p:spPr>
           <a:xfrm>
-            <a:off x="731520" y="457200"/>
+            <a:off x="731520" y="365760"/>
             <a:ext cx="10698480" cy="1097280"/>
           </a:xfrm>
           <a:prstGeom prst="rect">
@@ -4111,7 +4101,7 @@
           <a:lstStyle/>
           <a:p>
             <a:pPr>
-              <a:defRPr sz="3600" b="1">
+              <a:defRPr sz="3200" b="1">
                 <a:solidFill>
                   <a:srgbClr val="F3F4F6"/>
                 </a:solidFill>
@@ -4119,12 +4109,12 @@
               </a:defRPr>
             </a:pPr>
             <a:r>
-              <a:t>Current Results &amp; Tuning Value</a:t>
-            </a:r>
-          </a:p>
-          <a:p>
-            <a:pPr>
-              <a:defRPr sz="1400" b="1">
+              <a:t>Multi-Agent System Architecture</a:t>
+            </a:r>
+          </a:p>
+          <a:p>
+            <a:pPr>
+              <a:defRPr sz="1300" b="1">
                 <a:solidFill>
                   <a:srgbClr val="38BDF8"/>
                 </a:solidFill>
@@ -4132,7 +4122,7 @@
               </a:defRPr>
             </a:pPr>
             <a:r>
-              <a:t>// Model Metrics</a:t>
+              <a:t>// Agent Execution Roles</a:t>
             </a:r>
           </a:p>
         </p:txBody>
@@ -4145,8 +4135,8 @@
         </p:nvSpPr>
         <p:spPr>
           <a:xfrm>
-            <a:off x="731520" y="1828800"/>
-            <a:ext cx="5943600" cy="4114800"/>
+            <a:off x="731520" y="1645920"/>
+            <a:ext cx="5120640" cy="4572000"/>
           </a:xfrm>
           <a:prstGeom prst="rect">
             <a:avLst/>
@@ -4161,9 +4151,9 @@
           <a:p>
             <a:pPr>
               <a:spcAft>
-                <a:spcPts val="400"/>
-              </a:spcAft>
-              <a:defRPr sz="1800" b="1">
+                <a:spcPts val="200"/>
+              </a:spcAft>
+              <a:defRPr sz="1500" b="1">
                 <a:solidFill>
                   <a:srgbClr val="F3F4F6"/>
                 </a:solidFill>
@@ -4171,15 +4161,15 @@
               </a:defRPr>
             </a:pPr>
             <a:r>
-              <a:t>• Random Baseline Benchmark</a:t>
-            </a:r>
-          </a:p>
-          <a:p>
-            <a:pPr>
-              <a:spcAft>
-                <a:spcPts val="1600"/>
-              </a:spcAft>
-              <a:defRPr sz="1400">
+              <a:t>• Atlas (Product Owner)</a:t>
+            </a:r>
+          </a:p>
+          <a:p>
+            <a:pPr>
+              <a:spcAft>
+                <a:spcPts val="1200"/>
+              </a:spcAft>
+              <a:defRPr sz="1200">
                 <a:solidFill>
                   <a:srgbClr val="9CA3AF"/>
                 </a:solidFill>
@@ -4187,15 +4177,15 @@
               </a:defRPr>
             </a:pPr>
             <a:r>
-              <a:t>  HOSR: 79.25% | PP Rate: 1.39% | Mean Reward: 38.47.</a:t>
-            </a:r>
-          </a:p>
-          <a:p>
-            <a:pPr>
-              <a:spcAft>
-                <a:spcPts val="400"/>
-              </a:spcAft>
-              <a:defRPr sz="1800" b="1">
+              <a:t>  Orchestrates sprint goals, phase gates, daily reports, and blocker escalations.</a:t>
+            </a:r>
+          </a:p>
+          <a:p>
+            <a:pPr>
+              <a:spcAft>
+                <a:spcPts val="200"/>
+              </a:spcAft>
+              <a:defRPr sz="1500" b="1">
                 <a:solidFill>
                   <a:srgbClr val="F3F4F6"/>
                 </a:solidFill>
@@ -4203,15 +4193,15 @@
               </a:defRPr>
             </a:pPr>
             <a:r>
-              <a:t>• Trained PPO Agent (100k steps)</a:t>
-            </a:r>
-          </a:p>
-          <a:p>
-            <a:pPr>
-              <a:spcAft>
-                <a:spcPts val="1600"/>
-              </a:spcAft>
-              <a:defRPr sz="1400">
+              <a:t>• Pipeline (Data Engineer)</a:t>
+            </a:r>
+          </a:p>
+          <a:p>
+            <a:pPr>
+              <a:spcAft>
+                <a:spcPts val="1200"/>
+              </a:spcAft>
+              <a:defRPr sz="1200">
                 <a:solidFill>
                   <a:srgbClr val="9CA3AF"/>
                 </a:solidFill>
@@ -4219,15 +4209,15 @@
               </a:defRPr>
             </a:pPr>
             <a:r>
-              <a:t>  HOSR: 79.27% | Mean Reward: 8,304,784.40 (Robust Policy Convergence).</a:t>
-            </a:r>
-          </a:p>
-          <a:p>
-            <a:pPr>
-              <a:spcAft>
-                <a:spcPts val="400"/>
-              </a:spcAft>
-              <a:defRPr sz="1800" b="1">
+              <a:t>  Responsible for CSV ingestion, schema mapper auto-detection, data validation, and Parquet exports.</a:t>
+            </a:r>
+          </a:p>
+          <a:p>
+            <a:pPr>
+              <a:spcAft>
+                <a:spcPts val="200"/>
+              </a:spcAft>
+              <a:defRPr sz="1500" b="1">
                 <a:solidFill>
                   <a:srgbClr val="F3F4F6"/>
                 </a:solidFill>
@@ -4235,15 +4225,15 @@
               </a:defRPr>
             </a:pPr>
             <a:r>
-              <a:t>• Optuna Sweep Optimization</a:t>
-            </a:r>
-          </a:p>
-          <a:p>
-            <a:pPr>
-              <a:spcAft>
-                <a:spcPts val="1600"/>
-              </a:spcAft>
-              <a:defRPr sz="1400">
+              <a:t>• Spectrum (RF Domain Lead)</a:t>
+            </a:r>
+          </a:p>
+          <a:p>
+            <a:pPr>
+              <a:spcAft>
+                <a:spcPts val="1200"/>
+              </a:spcAft>
+              <a:defRPr sz="1200">
                 <a:solidFill>
                   <a:srgbClr val="9CA3AF"/>
                 </a:solidFill>
@@ -4251,11 +4241,39 @@
               </a:defRPr>
             </a:pPr>
             <a:r>
-              <a:t>  Best Trial: LR ~ 0.00056, batch_size: 128, n_steps: 2048, gamma ~ 0.9817.</a:t>
-            </a:r>
-            <a:br/>
-            <a:r>
-              <a:t>Yields highest reward: 8,311,482.33.</a:t>
+              <a:t>  RF domain expert. Enforces 3GPP constraints, configures valid CIO ranges, and guides reward calibration.</a:t>
+            </a:r>
+          </a:p>
+          <a:p>
+            <a:pPr>
+              <a:spcAft>
+                <a:spcPts val="200"/>
+              </a:spcAft>
+              <a:defRPr sz="1500" b="1">
+                <a:solidFill>
+                  <a:srgbClr val="F3F4F6"/>
+                </a:solidFill>
+                <a:latin typeface="Arial"/>
+              </a:defRPr>
+            </a:pPr>
+            <a:r>
+              <a:t>• Forge (ML Engineer)</a:t>
+            </a:r>
+          </a:p>
+          <a:p>
+            <a:pPr>
+              <a:spcAft>
+                <a:spcPts val="1200"/>
+              </a:spcAft>
+              <a:defRPr sz="1200">
+                <a:solidFill>
+                  <a:srgbClr val="9CA3AF"/>
+                </a:solidFill>
+                <a:latin typeface="Arial"/>
+              </a:defRPr>
+            </a:pPr>
+            <a:r>
+              <a:t>  Builds the Gymnasium environment, handles PPO convergence loops, and runs Optuna parameter sweeps.</a:t>
             </a:r>
           </a:p>
         </p:txBody>
@@ -4268,8 +4286,8 @@
         </p:nvSpPr>
         <p:spPr>
           <a:xfrm>
-            <a:off x="7132320" y="1828800"/>
-            <a:ext cx="4297680" cy="4114800"/>
+            <a:off x="6217920" y="1645920"/>
+            <a:ext cx="5120640" cy="4572000"/>
           </a:xfrm>
           <a:prstGeom prst="rect">
             <a:avLst/>
@@ -4277,32 +4295,16 @@
           <a:noFill/>
         </p:spPr>
         <p:txBody>
-          <a:bodyPr wrap="square">
+          <a:bodyPr wrap="square" lIns="0" tIns="0" rIns="0" bIns="0">
             <a:spAutoFit/>
           </a:bodyPr>
           <a:lstStyle/>
           <a:p>
             <a:pPr>
               <a:spcAft>
-                <a:spcPts val="2000"/>
-              </a:spcAft>
-              <a:defRPr sz="2200" b="1">
-                <a:solidFill>
-                  <a:srgbClr val="38BDF8"/>
-                </a:solidFill>
-                <a:latin typeface="Arial"/>
-              </a:defRPr>
-            </a:pPr>
-            <a:r>
-              <a:t>🎯 Key Metrics Summary:</a:t>
-            </a:r>
-          </a:p>
-          <a:p>
-            <a:pPr>
-              <a:spcAft>
-                <a:spcPts val="800"/>
-              </a:spcAft>
-              <a:defRPr sz="1800" b="1">
+                <a:spcPts val="200"/>
+              </a:spcAft>
+              <a:defRPr sz="1500" b="1">
                 <a:solidFill>
                   <a:srgbClr val="F3F4F6"/>
                 </a:solidFill>
@@ -4310,15 +4312,31 @@
               </a:defRPr>
             </a:pPr>
             <a:r>
-              <a:t>PPO Conv Reward: 8.30 Million</a:t>
-            </a:r>
-          </a:p>
-          <a:p>
-            <a:pPr>
-              <a:spcAft>
-                <a:spcPts val="800"/>
-              </a:spcAft>
-              <a:defRPr sz="1800" b="1">
+              <a:t>• Deploy (DevOps)</a:t>
+            </a:r>
+          </a:p>
+          <a:p>
+            <a:pPr>
+              <a:spcAft>
+                <a:spcPts val="1200"/>
+              </a:spcAft>
+              <a:defRPr sz="1200">
+                <a:solidFill>
+                  <a:srgbClr val="9CA3AF"/>
+                </a:solidFill>
+                <a:latin typeface="Arial"/>
+              </a:defRPr>
+            </a:pPr>
+            <a:r>
+              <a:t>  Docker containment, environment locks, and K8s manifests targeting CU-CP K8s pods.</a:t>
+            </a:r>
+          </a:p>
+          <a:p>
+            <a:pPr>
+              <a:spcAft>
+                <a:spcPts val="200"/>
+              </a:spcAft>
+              <a:defRPr sz="1500" b="1">
                 <a:solidFill>
                   <a:srgbClr val="F3F4F6"/>
                 </a:solidFill>
@@ -4326,15 +4344,31 @@
               </a:defRPr>
             </a:pPr>
             <a:r>
-              <a:t>Optuna Best Reward: 8.31 Million</a:t>
-            </a:r>
-          </a:p>
-          <a:p>
-            <a:pPr>
-              <a:spcAft>
-                <a:spcPts val="800"/>
-              </a:spcAft>
-              <a:defRPr sz="1800" b="1">
+              <a:t>• Lens (Visualization)</a:t>
+            </a:r>
+          </a:p>
+          <a:p>
+            <a:pPr>
+              <a:spcAft>
+                <a:spcPts val="1200"/>
+              </a:spcAft>
+              <a:defRPr sz="1200">
+                <a:solidFill>
+                  <a:srgbClr val="9CA3AF"/>
+                </a:solidFill>
+                <a:latin typeface="Arial"/>
+              </a:defRPr>
+            </a:pPr>
+            <a:r>
+              <a:t>  Generates interactive Streamlit dashboards, HTML presentations, and PowerPoint decks.</a:t>
+            </a:r>
+          </a:p>
+          <a:p>
+            <a:pPr>
+              <a:spcAft>
+                <a:spcPts val="200"/>
+              </a:spcAft>
+              <a:defRPr sz="1500" b="1">
                 <a:solidFill>
                   <a:srgbClr val="F3F4F6"/>
                 </a:solidFill>
@@ -4342,23 +4376,23 @@
               </a:defRPr>
             </a:pPr>
             <a:r>
-              <a:t>Success Rate (HOSR): 79.27%</a:t>
-            </a:r>
-          </a:p>
-          <a:p>
-            <a:pPr>
-              <a:spcAft>
-                <a:spcPts val="800"/>
-              </a:spcAft>
-              <a:defRPr sz="1800" b="1">
-                <a:solidFill>
-                  <a:srgbClr val="F3F4F6"/>
-                </a:solidFill>
-                <a:latin typeface="Arial"/>
-              </a:defRPr>
-            </a:pPr>
-            <a:r>
-              <a:t>Unit Verification: 144/144 tests passed</a:t>
+              <a:t>• Sentinel (QA &amp; Validation)</a:t>
+            </a:r>
+          </a:p>
+          <a:p>
+            <a:pPr>
+              <a:spcAft>
+                <a:spcPts val="1200"/>
+              </a:spcAft>
+              <a:defRPr sz="1200">
+                <a:solidFill>
+                  <a:srgbClr val="9CA3AF"/>
+                </a:solidFill>
+                <a:latin typeface="Arial"/>
+              </a:defRPr>
+            </a:pPr>
+            <a:r>
+              <a:t>  Property-based tests (Hypothesis), adversarial input audits, and automated ship gate verification.</a:t>
             </a:r>
           </a:p>
         </p:txBody>
@@ -4397,7 +4431,7 @@
         </p:nvSpPr>
         <p:spPr>
           <a:xfrm>
-            <a:off x="731520" y="457200"/>
+            <a:off x="731520" y="365760"/>
             <a:ext cx="10698480" cy="1097280"/>
           </a:xfrm>
           <a:prstGeom prst="rect">
@@ -4412,7 +4446,7 @@
           <a:lstStyle/>
           <a:p>
             <a:pPr>
-              <a:defRPr sz="3600" b="1">
+              <a:defRPr sz="3200" b="1">
                 <a:solidFill>
                   <a:srgbClr val="F3F4F6"/>
                 </a:solidFill>
@@ -4420,12 +4454,12 @@
               </a:defRPr>
             </a:pPr>
             <a:r>
-              <a:t>Phase 2 Outlook &amp; Roadmap</a:t>
-            </a:r>
-          </a:p>
-          <a:p>
-            <a:pPr>
-              <a:defRPr sz="1400" b="1">
+              <a:t>100k Sweep &amp; ONNX Export</a:t>
+            </a:r>
+          </a:p>
+          <a:p>
+            <a:pPr>
+              <a:defRPr sz="1300" b="1">
                 <a:solidFill>
                   <a:srgbClr val="38BDF8"/>
                 </a:solidFill>
@@ -4433,7 +4467,7 @@
               </a:defRPr>
             </a:pPr>
             <a:r>
-              <a:t>// Next Tasks</a:t>
+              <a:t>// Phase 3 Results</a:t>
             </a:r>
           </a:p>
         </p:txBody>
@@ -4446,8 +4480,8 @@
         </p:nvSpPr>
         <p:spPr>
           <a:xfrm>
-            <a:off x="731520" y="1828800"/>
-            <a:ext cx="5943600" cy="4114800"/>
+            <a:off x="731520" y="1645920"/>
+            <a:ext cx="5943600" cy="4572000"/>
           </a:xfrm>
           <a:prstGeom prst="rect">
             <a:avLst/>
@@ -4462,9 +4496,9 @@
           <a:p>
             <a:pPr>
               <a:spcAft>
-                <a:spcPts val="400"/>
-              </a:spcAft>
-              <a:defRPr sz="1800" b="1">
+                <a:spcPts val="200"/>
+              </a:spcAft>
+              <a:defRPr sz="1600" b="1">
                 <a:solidFill>
                   <a:srgbClr val="F3F4F6"/>
                 </a:solidFill>
@@ -4472,15 +4506,15 @@
               </a:defRPr>
             </a:pPr>
             <a:r>
-              <a:t>• ONNX Serialization &amp; Model Export</a:t>
-            </a:r>
-          </a:p>
-          <a:p>
-            <a:pPr>
-              <a:spcAft>
-                <a:spcPts val="1600"/>
-              </a:spcAft>
-              <a:defRPr sz="1400">
+              <a:t>• 100k Sweeps (16/16 Completed)</a:t>
+            </a:r>
+          </a:p>
+          <a:p>
+            <a:pPr>
+              <a:spcAft>
+                <a:spcPts val="1200"/>
+              </a:spcAft>
+              <a:defRPr sz="1300">
                 <a:solidFill>
                   <a:srgbClr val="9CA3AF"/>
                 </a:solidFill>
@@ -4488,15 +4522,15 @@
               </a:defRPr>
             </a:pPr>
             <a:r>
-              <a:t>  Convert Stable Baselines3 PyTorch model checkpoints to lightweight ONNX format to support high-frequency inference runtimes.</a:t>
-            </a:r>
-          </a:p>
-          <a:p>
-            <a:pPr>
-              <a:spcAft>
-                <a:spcPts val="400"/>
-              </a:spcAft>
-              <a:defRPr sz="1800" b="1">
+              <a:t>  PPO trained across 4 variants x 4 scenarios. Variant v2 baseline achieves HOSR: 99.99% and Ping-Pong: 0.00%.</a:t>
+            </a:r>
+          </a:p>
+          <a:p>
+            <a:pPr>
+              <a:spcAft>
+                <a:spcPts val="200"/>
+              </a:spcAft>
+              <a:defRPr sz="1600" b="1">
                 <a:solidFill>
                   <a:srgbClr val="F3F4F6"/>
                 </a:solidFill>
@@ -4504,15 +4538,15 @@
               </a:defRPr>
             </a:pPr>
             <a:r>
-              <a:t>• Production Deployment Pipeline</a:t>
-            </a:r>
-          </a:p>
-          <a:p>
-            <a:pPr>
-              <a:spcAft>
-                <a:spcPts val="1600"/>
-              </a:spcAft>
-              <a:defRPr sz="1400">
+              <a:t>• Optuna Hyperparameter Tuning</a:t>
+            </a:r>
+          </a:p>
+          <a:p>
+            <a:pPr>
+              <a:spcAft>
+                <a:spcPts val="1200"/>
+              </a:spcAft>
+              <a:defRPr sz="1300">
                 <a:solidFill>
                   <a:srgbClr val="9CA3AF"/>
                 </a:solidFill>
@@ -4520,15 +4554,15 @@
               </a:defRPr>
             </a:pPr>
             <a:r>
-              <a:t>  Create inference loader classes pulling serialized parameters to calculate live CIO adjustments on network controllers.</a:t>
-            </a:r>
-          </a:p>
-          <a:p>
-            <a:pPr>
-              <a:spcAft>
-                <a:spcPts val="400"/>
-              </a:spcAft>
-              <a:defRPr sz="1800" b="1">
+              <a:t>  Optimized learning rate, batch size, rollout steps, and discount factor to resolve baseline HOSR stagnation.</a:t>
+            </a:r>
+          </a:p>
+          <a:p>
+            <a:pPr>
+              <a:spcAft>
+                <a:spcPts val="200"/>
+              </a:spcAft>
+              <a:defRPr sz="1600" b="1">
                 <a:solidFill>
                   <a:srgbClr val="F3F4F6"/>
                 </a:solidFill>
@@ -4536,15 +4570,15 @@
               </a:defRPr>
             </a:pPr>
             <a:r>
-              <a:t>• MLflow Model Registry Integration</a:t>
-            </a:r>
-          </a:p>
-          <a:p>
-            <a:pPr>
-              <a:spcAft>
-                <a:spcPts val="1600"/>
-              </a:spcAft>
-              <a:defRPr sz="1400">
+              <a:t>• ONNX Exporter (Complete)</a:t>
+            </a:r>
+          </a:p>
+          <a:p>
+            <a:pPr>
+              <a:spcAft>
+                <a:spcPts val="1200"/>
+              </a:spcAft>
+              <a:defRPr sz="1300">
                 <a:solidFill>
                   <a:srgbClr val="9CA3AF"/>
                 </a:solidFill>
@@ -4552,15 +4586,15 @@
               </a:defRPr>
             </a:pPr>
             <a:r>
-              <a:t>  Register candidate checkpoints, audit tags (Staging, Production), and archive legacy runs.</a:t>
-            </a:r>
-          </a:p>
-          <a:p>
-            <a:pPr>
-              <a:spcAft>
-                <a:spcPts val="400"/>
-              </a:spcAft>
-              <a:defRPr sz="1800" b="1">
+              <a:t>  export_onnx.py converts PyTorch model zip checkpoint into deployment-ready ONNX models for CU-CP K8s deployment.</a:t>
+            </a:r>
+          </a:p>
+          <a:p>
+            <a:pPr>
+              <a:spcAft>
+                <a:spcPts val="200"/>
+              </a:spcAft>
+              <a:defRPr sz="1600" b="1">
                 <a:solidFill>
                   <a:srgbClr val="F3F4F6"/>
                 </a:solidFill>
@@ -4568,15 +4602,15 @@
               </a:defRPr>
             </a:pPr>
             <a:r>
-              <a:t>• In-Field Validation Framework</a:t>
-            </a:r>
-          </a:p>
-          <a:p>
-            <a:pPr>
-              <a:spcAft>
-                <a:spcPts val="1600"/>
-              </a:spcAft>
-              <a:defRPr sz="1400">
+              <a:t>• Tensor Clamping Bounds</a:t>
+            </a:r>
+          </a:p>
+          <a:p>
+            <a:pPr>
+              <a:spcAft>
+                <a:spcPts val="1200"/>
+              </a:spcAft>
+              <a:defRPr sz="1300">
                 <a:solidFill>
                   <a:srgbClr val="9CA3AF"/>
                 </a:solidFill>
@@ -4584,7 +4618,7 @@
               </a:defRPr>
             </a:pPr>
             <a:r>
-              <a:t>  Establish shadow deployment metrics to audit agent predictions against live cell-level performance telemetry before enforcement.</a:t>
+              <a:t>  Applied torch.clamp matching environment action limits [-2.0, 2.0] to guarantee ONNX predictions match SB3 deterministic predictions.</a:t>
             </a:r>
           </a:p>
         </p:txBody>
@@ -4597,8 +4631,8 @@
         </p:nvSpPr>
         <p:spPr>
           <a:xfrm>
-            <a:off x="7315200" y="1828800"/>
-            <a:ext cx="4114800" cy="4114800"/>
+            <a:off x="7132320" y="1645920"/>
+            <a:ext cx="4297680" cy="4572000"/>
           </a:xfrm>
           <a:prstGeom prst="rect">
             <a:avLst/>
@@ -4613,7 +4647,7 @@
           <a:p>
             <a:pPr>
               <a:spcAft>
-                <a:spcPts val="1400"/>
+                <a:spcPts val="1600"/>
               </a:spcAft>
               <a:defRPr sz="2200" b="1">
                 <a:solidFill>
@@ -4623,20 +4657,87 @@
               </a:defRPr>
             </a:pPr>
             <a:r>
-              <a:t>Phase 2 Target:</a:t>
-            </a:r>
-          </a:p>
-          <a:p>
-            <a:pPr>
-              <a:defRPr sz="1600">
-                <a:solidFill>
-                  <a:srgbClr val="9CA3AF"/>
-                </a:solidFill>
-                <a:latin typeface="Arial"/>
-              </a:defRPr>
-            </a:pPr>
-            <a:r>
-              <a:t>Transitioning the offline training pipeline into a production-grade inference engine serving optimization updates directly to network controllers.</a:t>
+              <a:t>🎯 Verification Performance</a:t>
+            </a:r>
+          </a:p>
+          <a:p>
+            <a:pPr>
+              <a:spcAft>
+                <a:spcPts val="400"/>
+              </a:spcAft>
+              <a:defRPr sz="1600" b="1">
+                <a:solidFill>
+                  <a:srgbClr val="F3F4F6"/>
+                </a:solidFill>
+                <a:latin typeface="Arial"/>
+              </a:defRPr>
+            </a:pPr>
+            <a:r>
+              <a:t>• Random Baseline HOSR: 79.25%</a:t>
+            </a:r>
+          </a:p>
+          <a:p>
+            <a:pPr>
+              <a:spcAft>
+                <a:spcPts val="400"/>
+              </a:spcAft>
+              <a:defRPr sz="1600" b="1">
+                <a:solidFill>
+                  <a:srgbClr val="F3F4F6"/>
+                </a:solidFill>
+                <a:latin typeface="Arial"/>
+              </a:defRPr>
+            </a:pPr>
+            <a:r>
+              <a:t>• Trained Agent HOSR: 99.99%</a:t>
+            </a:r>
+          </a:p>
+          <a:p>
+            <a:pPr>
+              <a:spcAft>
+                <a:spcPts val="400"/>
+              </a:spcAft>
+              <a:defRPr sz="1600" b="1">
+                <a:solidFill>
+                  <a:srgbClr val="F3F4F6"/>
+                </a:solidFill>
+                <a:latin typeface="Arial"/>
+              </a:defRPr>
+            </a:pPr>
+            <a:r>
+              <a:t>• Absolute HOSR Delta: +20.74%</a:t>
+            </a:r>
+          </a:p>
+          <a:p>
+            <a:pPr>
+              <a:spcAft>
+                <a:spcPts val="400"/>
+              </a:spcAft>
+              <a:defRPr sz="1600" b="1">
+                <a:solidFill>
+                  <a:srgbClr val="F3F4F6"/>
+                </a:solidFill>
+                <a:latin typeface="Arial"/>
+              </a:defRPr>
+            </a:pPr>
+            <a:r>
+              <a:t>• Trained Agent PP Rate: 0.00%</a:t>
+            </a:r>
+          </a:p>
+          <a:p>
+            <a:pPr>
+              <a:spcAft>
+                <a:spcPts val="400"/>
+              </a:spcAft>
+              <a:defRPr sz="1600" b="1">
+                <a:solidFill>
+                  <a:srgbClr val="F3F4F6"/>
+                </a:solidFill>
+                <a:latin typeface="Arial"/>
+              </a:defRPr>
+            </a:pPr>
+            <a:r>
+              <a:t>• Regression Tests: 262/262 passed</a:t>
             </a:r>
           </a:p>
         </p:txBody>

</xml_diff>